<commit_message>
Kamchatka deck: measure distance from Kazan, drop criterion labels
The location slide and its speech now use Kazan instead of Moscow
(about 6300 km, same +9 h time difference). The UNESCO criteria
cards no longer show the roman-numeral criterion labels.

Co-Authored-By: Claude Opus 5.5 <noreply@anthropic.com>
Claude-Session: https://claude.ai/code/session_016zrvTGhVNwvaX5P5wAX8tW
</commit_message>
<xml_diff>
--- a/presentations/kamchatka/Вулканы_Камчатки.pptx
+++ b/presentations/kamchatka/Вулканы_Камчатки.pptx
@@ -118,20 +118,20 @@
   <p:extLst>
     <p:ext uri="{521415D9-36F7-43E2-AB2F-B90AF26B5E84}">
       <p14:sectionLst xmlns:p14="http://schemas.microsoft.com/office/powerpoint/2010/main">
-        <p14:section name="Введение" id="{6bb2a289-b302-2430-1484-647b61182bb1}">
+        <p14:section name="Введение" id="{d0041378-665b-e643-c6cb-8befaad195ba}">
           <p14:sldIdLst>
             <p14:sldId id="256"/>
             <p14:sldId id="257"/>
           </p14:sldIdLst>
         </p14:section>
-        <p14:section name="География" id="{33012321-769e-5798-345e-e63eda3448d8}">
+        <p14:section name="География" id="{75818437-9f27-421a-2933-eea04394b0a4}">
           <p14:sldIdLst>
             <p14:sldId id="258"/>
             <p14:sldId id="259"/>
             <p14:sldId id="260"/>
           </p14:sldIdLst>
         </p14:section>
-        <p14:section name="Чудеса природы" id="{453686b3-8fcf-666e-37b5-b03ff2850721}">
+        <p14:section name="Чудеса природы" id="{a38b742a-7d67-59a1-9d61-c6b4b399dd28}">
           <p14:sldIdLst>
             <p14:sldId id="261"/>
             <p14:sldId id="262"/>
@@ -139,13 +139,13 @@
             <p14:sldId id="264"/>
           </p14:sldIdLst>
         </p14:section>
-        <p14:section name="Охрана" id="{fa193aaa-1e70-c296-8511-c6524f46e42b}">
+        <p14:section name="Охрана" id="{6f16224f-2a9e-3c62-e1dc-5dec969064e4}">
           <p14:sldIdLst>
             <p14:sldId id="265"/>
             <p14:sldId id="266"/>
           </p14:sldIdLst>
         </p14:section>
-        <p14:section name="Итог" id="{ec97e5de-2917-126b-9bf6-839a6049c129}">
+        <p14:section name="Итог" id="{5b0376c2-ff4a-8416-274e-45ea96ba8c65}">
           <p14:sldIdLst>
             <p14:sldId id="267"/>
           </p14:sldIdLst>
@@ -1333,7 +1333,7 @@
             <a:r>
               <a:rPr lang="en-US" dirty="0"/>
               <a:t>Камчатка — это полуостров на северо-востоке России. С запада его омывает Охотское море, с востока — Берингово море и Тихий океан. Полуостров вытянут с севера на юг примерно на 1200 километров.
-От Москвы до Петропавловска-Камчатского — почти 6800 километров, лететь на самолёте около девяти часов. А разница во времени — целых 9 часов: когда в Москве 9 утра, на Камчатке уже 6 вечера.
+От Казани до Петропавловска-Камчатского — около 6300 километров по прямой. А разница во времени — целых 9 часов: когда в Казани 9 утра, на Камчатке уже 6 вечера.
 Интересно, что автомобильной дороги на «большую землю» нет: на Камчатку можно попасть только самолётом или по морю.</a:t>
             </a:r>
             <a:endParaRPr lang="en-US" dirty="0"/>
@@ -3259,43 +3259,7 @@
       </p:pic>
       <p:sp>
         <p:nvSpPr>
-          <p:cNvPr id="10" name="Criterion 1 tag"/>
-          <p:cNvSpPr txBox="1"/>
-          <p:nvPr/>
-        </p:nvSpPr>
-        <p:spPr>
-          <a:xfrm>
-            <a:off x="5440680" y="1755648"/>
-            <a:ext cx="2141068" cy="365760"/>
-          </a:xfrm>
-          <a:prstGeom prst="rect">
-            <a:avLst/>
-          </a:prstGeom>
-          <a:noFill/>
-          <a:ln/>
-        </p:spPr>
-        <p:txBody>
-          <a:bodyPr wrap="square" lIns="0" tIns="0" rIns="0" bIns="0" rtlCol="0" anchor="ctr"/>
-          <a:lstStyle/>
-          <a:p>
-            <a:pPr indent="0" marL="0">
-              <a:buNone/>
-            </a:pPr>
-            <a:r>
-              <a:rPr lang="en-US" sz="1200" dirty="0">
-                <a:solidFill>
-                  <a:schemeClr val="tx2"/>
-                </a:solidFill>
-              </a:rPr>
-              <a:t>критерий vii</a:t>
-            </a:r>
-            <a:endParaRPr lang="en-US" sz="1200" dirty="0"/>
-          </a:p>
-        </p:txBody>
-      </p:sp>
-      <p:sp>
-        <p:nvSpPr>
-          <p:cNvPr id="11" name="Criterion 1 text"/>
+          <p:cNvPr id="10" name="Criterion 1 text"/>
           <p:cNvSpPr txBox="1"/>
           <p:nvPr/>
         </p:nvSpPr>
@@ -3351,7 +3315,7 @@
       </p:sp>
       <p:sp>
         <p:nvSpPr>
-          <p:cNvPr id="12" name="Criterion 2 card"/>
+          <p:cNvPr id="11" name="Criterion 2 card"/>
           <p:cNvSpPr/>
           <p:nvPr/>
         </p:nvSpPr>
@@ -3373,7 +3337,7 @@
       </p:sp>
       <p:sp>
         <p:nvSpPr>
-          <p:cNvPr id="13" name="Criterion 2 circle"/>
+          <p:cNvPr id="12" name="Criterion 2 circle"/>
           <p:cNvSpPr/>
           <p:nvPr/>
         </p:nvSpPr>
@@ -3393,7 +3357,7 @@
       </p:sp>
       <p:pic>
         <p:nvPicPr>
-          <p:cNvPr id="14" name="Criterion 2 icon" descr="preencoded.png">    </p:cNvPr>
+          <p:cNvPr id="13" name="Criterion 2 icon" descr="preencoded.png">    </p:cNvPr>
           <p:cNvPicPr>
             <a:picLocks noChangeAspect="1"/>
           </p:cNvPicPr>
@@ -3417,43 +3381,7 @@
       </p:pic>
       <p:sp>
         <p:nvSpPr>
-          <p:cNvPr id="15" name="Criterion 2 tag"/>
-          <p:cNvSpPr txBox="1"/>
-          <p:nvPr/>
-        </p:nvSpPr>
-        <p:spPr>
-          <a:xfrm>
-            <a:off x="9227668" y="1755648"/>
-            <a:ext cx="2141068" cy="365760"/>
-          </a:xfrm>
-          <a:prstGeom prst="rect">
-            <a:avLst/>
-          </a:prstGeom>
-          <a:noFill/>
-          <a:ln/>
-        </p:spPr>
-        <p:txBody>
-          <a:bodyPr wrap="square" lIns="0" tIns="0" rIns="0" bIns="0" rtlCol="0" anchor="ctr"/>
-          <a:lstStyle/>
-          <a:p>
-            <a:pPr indent="0" marL="0">
-              <a:buNone/>
-            </a:pPr>
-            <a:r>
-              <a:rPr lang="en-US" sz="1200" dirty="0">
-                <a:solidFill>
-                  <a:schemeClr val="tx2"/>
-                </a:solidFill>
-              </a:rPr>
-              <a:t>критерий viii</a:t>
-            </a:r>
-            <a:endParaRPr lang="en-US" sz="1200" dirty="0"/>
-          </a:p>
-        </p:txBody>
-      </p:sp>
-      <p:sp>
-        <p:nvSpPr>
-          <p:cNvPr id="16" name="Criterion 2 text"/>
+          <p:cNvPr id="14" name="Criterion 2 text"/>
           <p:cNvSpPr txBox="1"/>
           <p:nvPr/>
         </p:nvSpPr>
@@ -3509,7 +3437,7 @@
       </p:sp>
       <p:sp>
         <p:nvSpPr>
-          <p:cNvPr id="17" name="Criterion 3 card"/>
+          <p:cNvPr id="15" name="Criterion 3 card"/>
           <p:cNvSpPr/>
           <p:nvPr/>
         </p:nvSpPr>
@@ -3531,7 +3459,7 @@
       </p:sp>
       <p:sp>
         <p:nvSpPr>
-          <p:cNvPr id="18" name="Criterion 3 circle"/>
+          <p:cNvPr id="16" name="Criterion 3 circle"/>
           <p:cNvSpPr/>
           <p:nvPr/>
         </p:nvSpPr>
@@ -3551,7 +3479,7 @@
       </p:sp>
       <p:pic>
         <p:nvPicPr>
-          <p:cNvPr id="19" name="Criterion 3 icon" descr="preencoded.png">    </p:cNvPr>
+          <p:cNvPr id="17" name="Criterion 3 icon" descr="preencoded.png">    </p:cNvPr>
           <p:cNvPicPr>
             <a:picLocks noChangeAspect="1"/>
           </p:cNvPicPr>
@@ -3575,43 +3503,7 @@
       </p:pic>
       <p:sp>
         <p:nvSpPr>
-          <p:cNvPr id="20" name="Criterion 3 tag"/>
-          <p:cNvSpPr txBox="1"/>
-          <p:nvPr/>
-        </p:nvSpPr>
-        <p:spPr>
-          <a:xfrm>
-            <a:off x="5440680" y="4407408"/>
-            <a:ext cx="2141068" cy="365760"/>
-          </a:xfrm>
-          <a:prstGeom prst="rect">
-            <a:avLst/>
-          </a:prstGeom>
-          <a:noFill/>
-          <a:ln/>
-        </p:spPr>
-        <p:txBody>
-          <a:bodyPr wrap="square" lIns="0" tIns="0" rIns="0" bIns="0" rtlCol="0" anchor="ctr"/>
-          <a:lstStyle/>
-          <a:p>
-            <a:pPr indent="0" marL="0">
-              <a:buNone/>
-            </a:pPr>
-            <a:r>
-              <a:rPr lang="en-US" sz="1200" dirty="0">
-                <a:solidFill>
-                  <a:schemeClr val="tx2"/>
-                </a:solidFill>
-              </a:rPr>
-              <a:t>критерий ix</a:t>
-            </a:r>
-            <a:endParaRPr lang="en-US" sz="1200" dirty="0"/>
-          </a:p>
-        </p:txBody>
-      </p:sp>
-      <p:sp>
-        <p:nvSpPr>
-          <p:cNvPr id="21" name="Criterion 3 text"/>
+          <p:cNvPr id="18" name="Criterion 3 text"/>
           <p:cNvSpPr txBox="1"/>
           <p:nvPr/>
         </p:nvSpPr>
@@ -3667,7 +3559,7 @@
       </p:sp>
       <p:sp>
         <p:nvSpPr>
-          <p:cNvPr id="22" name="Criterion 4 card"/>
+          <p:cNvPr id="19" name="Criterion 4 card"/>
           <p:cNvSpPr/>
           <p:nvPr/>
         </p:nvSpPr>
@@ -3689,7 +3581,7 @@
       </p:sp>
       <p:sp>
         <p:nvSpPr>
-          <p:cNvPr id="23" name="Criterion 4 circle"/>
+          <p:cNvPr id="20" name="Criterion 4 circle"/>
           <p:cNvSpPr/>
           <p:nvPr/>
         </p:nvSpPr>
@@ -3709,7 +3601,7 @@
       </p:sp>
       <p:pic>
         <p:nvPicPr>
-          <p:cNvPr id="24" name="Criterion 4 icon" descr="preencoded.png">    </p:cNvPr>
+          <p:cNvPr id="21" name="Criterion 4 icon" descr="preencoded.png">    </p:cNvPr>
           <p:cNvPicPr>
             <a:picLocks noChangeAspect="1"/>
           </p:cNvPicPr>
@@ -3733,43 +3625,7 @@
       </p:pic>
       <p:sp>
         <p:nvSpPr>
-          <p:cNvPr id="25" name="Criterion 4 tag"/>
-          <p:cNvSpPr txBox="1"/>
-          <p:nvPr/>
-        </p:nvSpPr>
-        <p:spPr>
-          <a:xfrm>
-            <a:off x="9227668" y="4407408"/>
-            <a:ext cx="2141068" cy="365760"/>
-          </a:xfrm>
-          <a:prstGeom prst="rect">
-            <a:avLst/>
-          </a:prstGeom>
-          <a:noFill/>
-          <a:ln/>
-        </p:spPr>
-        <p:txBody>
-          <a:bodyPr wrap="square" lIns="0" tIns="0" rIns="0" bIns="0" rtlCol="0" anchor="ctr"/>
-          <a:lstStyle/>
-          <a:p>
-            <a:pPr indent="0" marL="0">
-              <a:buNone/>
-            </a:pPr>
-            <a:r>
-              <a:rPr lang="en-US" sz="1200" dirty="0">
-                <a:solidFill>
-                  <a:schemeClr val="tx2"/>
-                </a:solidFill>
-              </a:rPr>
-              <a:t>критерий x</a:t>
-            </a:r>
-            <a:endParaRPr lang="en-US" sz="1200" dirty="0"/>
-          </a:p>
-        </p:txBody>
-      </p:sp>
-      <p:sp>
-        <p:nvSpPr>
-          <p:cNvPr id="26" name="Criterion 4 text"/>
+          <p:cNvPr id="22" name="Criterion 4 text"/>
           <p:cNvSpPr txBox="1"/>
           <p:nvPr/>
         </p:nvSpPr>
@@ -5911,7 +5767,7 @@
       </p:sp>
       <p:pic>
         <p:nvPicPr>
-          <p:cNvPr id="4" name="Locator map" descr="Карта: путь от Москвы до Камчатки">    </p:cNvPr>
+          <p:cNvPr id="4" name="Locator map" descr="Карта: путь от Казани до Камчатки">    </p:cNvPr>
           <p:cNvPicPr>
             <a:picLocks noChangeAspect="1"/>
           </p:cNvPicPr>
@@ -5926,7 +5782,7 @@
         <p:spPr>
           <a:xfrm>
             <a:off x="548640" y="1371600"/>
-            <a:ext cx="6949440" cy="3817849"/>
+            <a:ext cx="6949440" cy="3898201"/>
           </a:xfrm>
           <a:prstGeom prst="rect">
             <a:avLst/>
@@ -5935,13 +5791,13 @@
       </p:pic>
       <p:sp>
         <p:nvSpPr>
-          <p:cNvPr id="5" name="Label Moscow"/>
+          <p:cNvPr id="5" name="Label Kazan"/>
           <p:cNvSpPr txBox="1"/>
           <p:nvPr/>
         </p:nvSpPr>
         <p:spPr>
           <a:xfrm>
-            <a:off x="908880" y="2666646"/>
+            <a:off x="1169282" y="3148469"/>
             <a:ext cx="1280160" cy="292608"/>
           </a:xfrm>
           <a:prstGeom prst="rect">
@@ -5963,7 +5819,7 @@
                   <a:schemeClr val="tx1"/>
                 </a:solidFill>
               </a:rPr>
-              <a:t>Москва</a:t>
+              <a:t>Казань</a:t>
             </a:r>
             <a:endParaRPr lang="en-US" sz="1500" dirty="0"/>
           </a:p>
@@ -5977,7 +5833,7 @@
         </p:nvSpPr>
         <p:spPr>
           <a:xfrm>
-            <a:off x="5055804" y="3006138"/>
+            <a:off x="5037888" y="3036691"/>
             <a:ext cx="1463040" cy="310896"/>
           </a:xfrm>
           <a:prstGeom prst="rect">
@@ -6013,7 +5869,7 @@
         </p:nvSpPr>
         <p:spPr>
           <a:xfrm>
-            <a:off x="3154680" y="1907694"/>
+            <a:off x="3126445" y="2389517"/>
             <a:ext cx="1691640" cy="384048"/>
           </a:xfrm>
           <a:prstGeom prst="roundRect">
@@ -6040,7 +5896,7 @@
         </p:nvSpPr>
         <p:spPr>
           <a:xfrm>
-            <a:off x="3154680" y="1907694"/>
+            <a:off x="3126445" y="2389517"/>
             <a:ext cx="1691640" cy="384048"/>
           </a:xfrm>
           <a:prstGeom prst="rect">
@@ -6062,7 +5918,7 @@
                   <a:schemeClr val="tx1"/>
                 </a:solidFill>
               </a:rPr>
-              <a:t>≈ 6 800 км</a:t>
+              <a:t>≈ 6 300 км</a:t>
             </a:r>
             <a:endParaRPr lang="en-US" sz="1600" dirty="0"/>
           </a:p>
@@ -6212,7 +6068,7 @@
                   <a:schemeClr val="tx2"/>
                 </a:solidFill>
               </a:rPr>
-              <a:t>разница с Москвой</a:t>
+              <a:t>разница с Казанью</a:t>
             </a:r>
             <a:endParaRPr lang="en-US" sz="1500" dirty="0"/>
           </a:p>

</xml_diff>

<commit_message>
Kamchatka deck: remove source credits, add PDF versions
Photo and map credits and the sources block are gone from the slides;
photo captions keep only what the picture shows. The deck and the
speech are now also exported as PDF.

Co-Authored-By: Claude Opus 5.5 <noreply@anthropic.com>
Claude-Session: https://claude.ai/code/session_016zrvTGhVNwvaX5P5wAX8tW
</commit_message>
<xml_diff>
--- a/presentations/kamchatka/Вулканы_Камчатки.pptx
+++ b/presentations/kamchatka/Вулканы_Камчатки.pptx
@@ -118,20 +118,20 @@
   <p:extLst>
     <p:ext uri="{521415D9-36F7-43E2-AB2F-B90AF26B5E84}">
       <p14:sectionLst xmlns:p14="http://schemas.microsoft.com/office/powerpoint/2010/main">
-        <p14:section name="Введение" id="{d0041378-665b-e643-c6cb-8befaad195ba}">
+        <p14:section name="Введение" id="{c0af029c-da08-17c8-e85f-dd9f9c4537d0}">
           <p14:sldIdLst>
             <p14:sldId id="256"/>
             <p14:sldId id="257"/>
           </p14:sldIdLst>
         </p14:section>
-        <p14:section name="География" id="{75818437-9f27-421a-2933-eea04394b0a4}">
+        <p14:section name="География" id="{d8a4da22-f71a-30bb-e589-fbdadf33af1f}">
           <p14:sldIdLst>
             <p14:sldId id="258"/>
             <p14:sldId id="259"/>
             <p14:sldId id="260"/>
           </p14:sldIdLst>
         </p14:section>
-        <p14:section name="Чудеса природы" id="{a38b742a-7d67-59a1-9d61-c6b4b399dd28}">
+        <p14:section name="Чудеса природы" id="{806d56c0-74f6-7d45-e3eb-db32f5896bbf}">
           <p14:sldIdLst>
             <p14:sldId id="261"/>
             <p14:sldId id="262"/>
@@ -139,13 +139,13 @@
             <p14:sldId id="264"/>
           </p14:sldIdLst>
         </p14:section>
-        <p14:section name="Охрана" id="{6f16224f-2a9e-3c62-e1dc-5dec969064e4}">
+        <p14:section name="Охрана" id="{4c784671-5646-6c58-9af3-deb74ea05475}">
           <p14:sldIdLst>
             <p14:sldId id="265"/>
             <p14:sldId id="266"/>
           </p14:sldIdLst>
         </p14:section>
-        <p14:section name="Итог" id="{5b0376c2-ff4a-8416-274e-45ea96ba8c65}">
+        <p14:section name="Итог" id="{c832c7f8-4175-656f-3a42-e4fc698d8040}">
           <p14:sldIdLst>
             <p14:sldId id="267"/>
           </p14:sldIdLst>
@@ -2981,42 +2981,6 @@
           </a:p>
         </p:txBody>
       </p:sp>
-      <p:sp>
-        <p:nvSpPr>
-          <p:cNvPr id="8" name="Photo credit"/>
-          <p:cNvSpPr txBox="1"/>
-          <p:nvPr/>
-        </p:nvSpPr>
-        <p:spPr>
-          <a:xfrm>
-            <a:off x="7071055" y="6400800"/>
-            <a:ext cx="4572000" cy="274320"/>
-          </a:xfrm>
-          <a:prstGeom prst="rect">
-            <a:avLst/>
-          </a:prstGeom>
-          <a:noFill/>
-          <a:ln/>
-        </p:spPr>
-        <p:txBody>
-          <a:bodyPr wrap="square" lIns="0" tIns="0" rIns="0" bIns="0" rtlCol="0" anchor="t"/>
-          <a:lstStyle/>
-          <a:p>
-            <a:pPr algn="r" indent="0" marL="0">
-              <a:buNone/>
-            </a:pPr>
-            <a:r>
-              <a:rPr lang="en-US" sz="1000" dirty="0">
-                <a:solidFill>
-                  <a:schemeClr val="bg2"/>
-                </a:solidFill>
-              </a:rPr>
-              <a:t>Фото: Игорь Шпиленок, Wikimedia Commons, CC BY-SA 3.0</a:t>
-            </a:r>
-            <a:endParaRPr lang="en-US" sz="1000" dirty="0"/>
-          </a:p>
-        </p:txBody>
-      </p:sp>
     </p:spTree>
   </p:cSld>
   <p:clrMapOvr>
@@ -4734,7 +4698,7 @@
                   <a:schemeClr val="bg1"/>
                 </a:solidFill>
               </a:rPr>
-              <a:t>Кроноцкая сопка, вид с МКС · фото: NASA/Chris Williams</a:t>
+              <a:t>Кроноцкая сопка, вид с МКС</a:t>
             </a:r>
             <a:endParaRPr lang="en-US" sz="1000" dirty="0"/>
           </a:p>
@@ -4850,90 +4814,6 @@
               <a:t>Спасибо за внимание!</a:t>
             </a:r>
             <a:endParaRPr lang="en-US" sz="3000" dirty="0"/>
-          </a:p>
-        </p:txBody>
-      </p:sp>
-      <p:sp>
-        <p:nvSpPr>
-          <p:cNvPr id="9" name="Sources"/>
-          <p:cNvSpPr txBox="1"/>
-          <p:nvPr/>
-        </p:nvSpPr>
-        <p:spPr>
-          <a:xfrm>
-            <a:off x="548640" y="5257800"/>
-            <a:ext cx="5394960" cy="1280160"/>
-          </a:xfrm>
-          <a:prstGeom prst="rect">
-            <a:avLst/>
-          </a:prstGeom>
-          <a:noFill/>
-          <a:ln/>
-        </p:spPr>
-        <p:txBody>
-          <a:bodyPr wrap="square" lIns="0" tIns="0" rIns="0" bIns="0" rtlCol="0" anchor="t"/>
-          <a:lstStyle/>
-          <a:p>
-            <a:pPr indent="0" marL="0">
-              <a:spcAft>
-                <a:spcPts val="300"/>
-              </a:spcAft>
-              <a:buNone/>
-            </a:pPr>
-            <a:r>
-              <a:rPr lang="en-US" sz="1000" b="1" dirty="0">
-                <a:solidFill>
-                  <a:schemeClr val="bg2"/>
-                </a:solidFill>
-              </a:rPr>
-              <a:t>Источники: </a:t>
-            </a:r>
-            <a:pPr indent="0" marL="0">
-              <a:spcAft>
-                <a:spcPts val="300"/>
-              </a:spcAft>
-              <a:buNone/>
-            </a:pPr>
-            <a:r>
-              <a:rPr lang="en-US" sz="1000" dirty="0">
-                <a:solidFill>
-                  <a:schemeClr val="bg2"/>
-                </a:solidFill>
-              </a:rPr>
-              <a:t>whc.unesco.org/ru/list/765; ru.wikipedia.org — статьи «Вулканы Камчатки», «Долина гейзеров», «Узон», «Курильское озеро», «Кроноцкий заповедник», «Ключевская Сопка».</a:t>
-            </a:r>
-            <a:endParaRPr lang="en-US" sz="1000" dirty="0"/>
-          </a:p>
-          <a:p>
-            <a:pPr indent="0" marL="0">
-              <a:spcAft>
-                <a:spcPts val="300"/>
-              </a:spcAft>
-              <a:buNone/>
-            </a:pPr>
-            <a:r>
-              <a:rPr lang="en-US" sz="1000" b="1" dirty="0">
-                <a:solidFill>
-                  <a:schemeClr val="bg2"/>
-                </a:solidFill>
-              </a:rPr>
-              <a:t>Фото и карты: </a:t>
-            </a:r>
-            <a:pPr indent="0" marL="0">
-              <a:spcAft>
-                <a:spcPts val="300"/>
-              </a:spcAft>
-              <a:buNone/>
-            </a:pPr>
-            <a:r>
-              <a:rPr lang="en-US" sz="1000" dirty="0">
-                <a:solidFill>
-                  <a:schemeClr val="bg2"/>
-                </a:solidFill>
-              </a:rPr>
-              <a:t>И. Шпиленок, Malupasic, R. Nunn, S. Pozdnyakov (Wikimedia Commons, CC BY-SA); W. Jongsma (Unsplash); NASA, NASA/JPL; Natural Earth.</a:t>
-            </a:r>
-            <a:endParaRPr lang="en-US" sz="1000" dirty="0"/>
           </a:p>
         </p:txBody>
       </p:sp>
@@ -6275,42 +6155,6 @@
       </p:sp>
       <p:sp>
         <p:nvSpPr>
-          <p:cNvPr id="18" name="Map credit"/>
-          <p:cNvSpPr txBox="1"/>
-          <p:nvPr/>
-        </p:nvSpPr>
-        <p:spPr>
-          <a:xfrm>
-            <a:off x="7907770" y="6446520"/>
-            <a:ext cx="3645634" cy="274320"/>
-          </a:xfrm>
-          <a:prstGeom prst="rect">
-            <a:avLst/>
-          </a:prstGeom>
-          <a:noFill/>
-          <a:ln/>
-        </p:spPr>
-        <p:txBody>
-          <a:bodyPr wrap="square" lIns="0" tIns="0" rIns="0" bIns="0" rtlCol="0" anchor="t"/>
-          <a:lstStyle/>
-          <a:p>
-            <a:pPr algn="ctr" indent="0" marL="0">
-              <a:buNone/>
-            </a:pPr>
-            <a:r>
-              <a:rPr lang="en-US" sz="1000" dirty="0">
-                <a:solidFill>
-                  <a:schemeClr val="tx2"/>
-                </a:solidFill>
-              </a:rPr>
-              <a:t>Рельеф Камчатки: NASA/JPL · карта: Natural Earth</a:t>
-            </a:r>
-            <a:endParaRPr lang="en-US" sz="1000" dirty="0"/>
-          </a:p>
-        </p:txBody>
-      </p:sp>
-      <p:sp>
-        <p:nvSpPr>
           <p:cNvPr id="25" name="Slide Number Placeholder 0"/>
           <p:cNvSpPr>
             <a:spLocks noGrp="1"/>
@@ -8317,7 +8161,7 @@
                   <a:schemeClr val="bg1"/>
                 </a:solidFill>
               </a:rPr>
-              <a:t>Ключевская сопка · фото: Malupasic, CC BY-SA 4.0</a:t>
+              <a:t>Ключевская сопка</a:t>
             </a:r>
             <a:endParaRPr lang="en-US" sz="1000" dirty="0"/>
           </a:p>
@@ -8562,65 +8406,7 @@
       </p:pic>
       <p:sp>
         <p:nvSpPr>
-          <p:cNvPr id="5" name="Photo caption bg"/>
-          <p:cNvSpPr/>
-          <p:nvPr/>
-        </p:nvSpPr>
-        <p:spPr>
-          <a:xfrm>
-            <a:off x="0" y="6547104"/>
-            <a:ext cx="5577840" cy="310896"/>
-          </a:xfrm>
-          <a:prstGeom prst="rect">
-            <a:avLst/>
-          </a:prstGeom>
-          <a:solidFill>
-            <a:schemeClr val="tx1">
-              <a:alpha val="65000"/>
-            </a:schemeClr>
-          </a:solidFill>
-          <a:ln/>
-        </p:spPr>
-      </p:sp>
-      <p:sp>
-        <p:nvSpPr>
-          <p:cNvPr id="6" name="Photo caption"/>
-          <p:cNvSpPr txBox="1"/>
-          <p:nvPr/>
-        </p:nvSpPr>
-        <p:spPr>
-          <a:xfrm>
-            <a:off x="109728" y="6547104"/>
-            <a:ext cx="5358384" cy="310896"/>
-          </a:xfrm>
-          <a:prstGeom prst="rect">
-            <a:avLst/>
-          </a:prstGeom>
-          <a:noFill/>
-          <a:ln/>
-        </p:spPr>
-        <p:txBody>
-          <a:bodyPr wrap="square" lIns="0" tIns="0" rIns="0" bIns="0" rtlCol="0" anchor="ctr"/>
-          <a:lstStyle/>
-          <a:p>
-            <a:pPr indent="0" marL="0">
-              <a:buNone/>
-            </a:pPr>
-            <a:r>
-              <a:rPr lang="en-US" sz="1000" dirty="0">
-                <a:solidFill>
-                  <a:schemeClr val="bg1"/>
-                </a:solidFill>
-              </a:rPr>
-              <a:t>Фото: Robert Nunn, CC BY-SA 2.0</a:t>
-            </a:r>
-            <a:endParaRPr lang="en-US" sz="1000" dirty="0"/>
-          </a:p>
-        </p:txBody>
-      </p:sp>
-      <p:sp>
-        <p:nvSpPr>
-          <p:cNvPr id="7" name="Geyser definition"/>
+          <p:cNvPr id="5" name="Geyser definition"/>
           <p:cNvSpPr txBox="1"/>
           <p:nvPr/>
         </p:nvSpPr>
@@ -8656,7 +8442,7 @@
       </p:sp>
       <p:sp>
         <p:nvSpPr>
-          <p:cNvPr id="8" name="Geysers row 1 circle"/>
+          <p:cNvPr id="6" name="Geysers row 1 circle"/>
           <p:cNvSpPr/>
           <p:nvPr/>
         </p:nvSpPr>
@@ -8676,7 +8462,7 @@
       </p:sp>
       <p:pic>
         <p:nvPicPr>
-          <p:cNvPr id="9" name="Geysers row 1 icon" descr="preencoded.png">    </p:cNvPr>
+          <p:cNvPr id="7" name="Geysers row 1 icon" descr="preencoded.png">    </p:cNvPr>
           <p:cNvPicPr>
             <a:picLocks noChangeAspect="1"/>
           </p:cNvPicPr>
@@ -8700,7 +8486,7 @@
       </p:pic>
       <p:sp>
         <p:nvSpPr>
-          <p:cNvPr id="10" name="Geysers row 1 text"/>
+          <p:cNvPr id="8" name="Geysers row 1 text"/>
           <p:cNvSpPr txBox="1"/>
           <p:nvPr/>
         </p:nvSpPr>
@@ -8756,7 +8542,7 @@
       </p:sp>
       <p:sp>
         <p:nvSpPr>
-          <p:cNvPr id="11" name="Geysers row 2 circle"/>
+          <p:cNvPr id="9" name="Geysers row 2 circle"/>
           <p:cNvSpPr/>
           <p:nvPr/>
         </p:nvSpPr>
@@ -8776,7 +8562,7 @@
       </p:sp>
       <p:pic>
         <p:nvPicPr>
-          <p:cNvPr id="12" name="Geysers row 2 icon" descr="preencoded.png">    </p:cNvPr>
+          <p:cNvPr id="10" name="Geysers row 2 icon" descr="preencoded.png">    </p:cNvPr>
           <p:cNvPicPr>
             <a:picLocks noChangeAspect="1"/>
           </p:cNvPicPr>
@@ -8800,7 +8586,7 @@
       </p:pic>
       <p:sp>
         <p:nvSpPr>
-          <p:cNvPr id="13" name="Geysers row 2 text"/>
+          <p:cNvPr id="11" name="Geysers row 2 text"/>
           <p:cNvSpPr txBox="1"/>
           <p:nvPr/>
         </p:nvSpPr>
@@ -8856,7 +8642,7 @@
       </p:sp>
       <p:sp>
         <p:nvSpPr>
-          <p:cNvPr id="14" name="Geysers row 3 circle"/>
+          <p:cNvPr id="12" name="Geysers row 3 circle"/>
           <p:cNvSpPr/>
           <p:nvPr/>
         </p:nvSpPr>
@@ -8876,7 +8662,7 @@
       </p:sp>
       <p:pic>
         <p:nvPicPr>
-          <p:cNvPr id="15" name="Geysers row 3 icon" descr="preencoded.png">    </p:cNvPr>
+          <p:cNvPr id="13" name="Geysers row 3 icon" descr="preencoded.png">    </p:cNvPr>
           <p:cNvPicPr>
             <a:picLocks noChangeAspect="1"/>
           </p:cNvPicPr>
@@ -8900,7 +8686,7 @@
       </p:pic>
       <p:sp>
         <p:nvSpPr>
-          <p:cNvPr id="16" name="Geysers row 3 text"/>
+          <p:cNvPr id="14" name="Geysers row 3 text"/>
           <p:cNvSpPr txBox="1"/>
           <p:nvPr/>
         </p:nvSpPr>
@@ -8956,7 +8742,7 @@
       </p:sp>
       <p:sp>
         <p:nvSpPr>
-          <p:cNvPr id="17" name="Geysers row 4 circle"/>
+          <p:cNvPr id="15" name="Geysers row 4 circle"/>
           <p:cNvSpPr/>
           <p:nvPr/>
         </p:nvSpPr>
@@ -8976,7 +8762,7 @@
       </p:sp>
       <p:pic>
         <p:nvPicPr>
-          <p:cNvPr id="18" name="Geysers row 4 icon" descr="preencoded.png">    </p:cNvPr>
+          <p:cNvPr id="16" name="Geysers row 4 icon" descr="preencoded.png">    </p:cNvPr>
           <p:cNvPicPr>
             <a:picLocks noChangeAspect="1"/>
           </p:cNvPicPr>
@@ -9000,7 +8786,7 @@
       </p:pic>
       <p:sp>
         <p:nvSpPr>
-          <p:cNvPr id="19" name="Geysers row 4 text"/>
+          <p:cNvPr id="17" name="Geysers row 4 text"/>
           <p:cNvSpPr txBox="1"/>
           <p:nvPr/>
         </p:nvSpPr>
@@ -9695,7 +9481,7 @@
                   <a:schemeClr val="bg1"/>
                 </a:solidFill>
               </a:rPr>
-              <a:t>Хлоридное озеро · фото: S. Pozdnyakov, CC BY-SA 3.0</a:t>
+              <a:t>Хлоридное озеро в кальдере Узон</a:t>
             </a:r>
             <a:endParaRPr lang="en-US" sz="1000" dirty="0"/>
           </a:p>
@@ -9885,7 +9671,7 @@
                   <a:schemeClr val="bg1"/>
                 </a:solidFill>
               </a:rPr>
-              <a:t>Медведь на Курильском озере · фото: Wietse Jongsma, Unsplash</a:t>
+              <a:t>Медведь на Курильском озере</a:t>
             </a:r>
             <a:endParaRPr lang="en-US" sz="1000" dirty="0"/>
           </a:p>

</xml_diff>

<commit_message>
Kamchatka deck: add the student's name to the title slide and speech
Co-Authored-By: Claude Opus 5.5 <noreply@anthropic.com>
Claude-Session: https://claude.ai/code/session_016zrvTGhVNwvaX5P5wAX8tW
</commit_message>
<xml_diff>
--- a/presentations/kamchatka/Вулканы_Камчатки.pptx
+++ b/presentations/kamchatka/Вулканы_Камчатки.pptx
@@ -118,20 +118,20 @@
   <p:extLst>
     <p:ext uri="{521415D9-36F7-43E2-AB2F-B90AF26B5E84}">
       <p14:sectionLst xmlns:p14="http://schemas.microsoft.com/office/powerpoint/2010/main">
-        <p14:section name="Введение" id="{c0af029c-da08-17c8-e85f-dd9f9c4537d0}">
+        <p14:section name="Введение" id="{11eef267-5200-0cd8-3d72-731911f324fb}">
           <p14:sldIdLst>
             <p14:sldId id="256"/>
             <p14:sldId id="257"/>
           </p14:sldIdLst>
         </p14:section>
-        <p14:section name="География" id="{d8a4da22-f71a-30bb-e589-fbdadf33af1f}">
+        <p14:section name="География" id="{49c7eec5-4c9d-5817-0d30-b48cfeedfe7c}">
           <p14:sldIdLst>
             <p14:sldId id="258"/>
             <p14:sldId id="259"/>
             <p14:sldId id="260"/>
           </p14:sldIdLst>
         </p14:section>
-        <p14:section name="Чудеса природы" id="{806d56c0-74f6-7d45-e3eb-db32f5896bbf}">
+        <p14:section name="Чудеса природы" id="{3052e977-7467-3704-fd20-d6f98caad6a8}">
           <p14:sldIdLst>
             <p14:sldId id="261"/>
             <p14:sldId id="262"/>
@@ -139,13 +139,13 @@
             <p14:sldId id="264"/>
           </p14:sldIdLst>
         </p14:section>
-        <p14:section name="Охрана" id="{4c784671-5646-6c58-9af3-deb74ea05475}">
+        <p14:section name="Охрана" id="{9f46f581-0377-52b0-2185-61bf0fb5c94d}">
           <p14:sldIdLst>
             <p14:sldId id="265"/>
             <p14:sldId id="266"/>
           </p14:sldIdLst>
         </p14:section>
-        <p14:section name="Итог" id="{c832c7f8-4175-656f-3a42-e4fc698d8040}">
+        <p14:section name="Итог" id="{87803996-2cbd-1773-fea6-842dabfd6085}">
           <p14:sldIdLst>
             <p14:sldId id="267"/>
           </p14:sldIdLst>
@@ -1154,7 +1154,7 @@
               <a:t>Подведу итог. Вулканы Камчатки — это место, где можно своими глазами увидеть, как живёт и меняется наша планета: здесь рождаются вулканы, бьют гейзеры, а лосось и медведи живут так же, как тысячи лет назад.
 Поэтому эта территория — достояние не только России, но и всего человечества, и наша общая задача — её сохранить.
 На фотографии — Кроноцкая сопка, снятая с Международной космической станции. Она почти идеально ровная, как японская гора Фудзи.
-Спасибо за внимание! Готов(а) ответить на ваши вопросы.</a:t>
+Спасибо за внимание! Готов ответить на ваши вопросы.</a:t>
             </a:r>
             <a:endParaRPr lang="en-US" dirty="0"/>
           </a:p>
@@ -2975,7 +2975,7 @@
                   <a:schemeClr val="bg1"/>
                 </a:solidFill>
               </a:rPr>
-              <a:t>Доклад ученика (ученицы) 8 класса · Фамилия Имя</a:t>
+              <a:t>Доклад ученика 8А класса Серазентдинова Артура</a:t>
             </a:r>
             <a:endParaRPr lang="en-US" sz="1800" dirty="0"/>
           </a:p>

</xml_diff>